<commit_message>
docs: align workshop guides, wiki, Pages, and decks
Align bilingual entry points, evidence screenshots, practice downloads, and generated decks.
Add cross-document and wiki regression checks.
Refs #58

📚 - Generated by Copilot
</commit_message>
<xml_diff>
--- a/docs/assets/decks/foundry-hosted-agents-workshop-fsi-en.pptx
+++ b/docs/assets/decks/foundry-hosted-agents-workshop-fsi-en.pptx
@@ -23,9 +23,11 @@
     <p:sldId id="271" r:id="rId17"/>
     <p:sldId id="272" r:id="rId18"/>
     <p:sldId id="273" r:id="rId19"/>
+    <p:sldId id="274" r:id="rId20"/>
+    <p:sldId id="275" r:id="rId21"/>
   </p:sldIdLst>
   <p:notesMasterIdLst>
-    <p:notesMasterId r:id="rId20"/>
+    <p:notesMasterId r:id="rId22"/>
   </p:notesMasterIdLst>
   <p:sldSz cx="12188952" cy="6858000"/>
   <p:notesSz cx="6858000" cy="12188952"/>
@@ -1311,7 +1313,8 @@
           <a:p>
             <a:r>
               <a:rPr lang="en-US" dirty="0"/>
-              <a:t/>
+              <a:t>Retained release 39527950931 attempt 2, source 2c3f13b. Staging IQ is fsi-showcase-iq:2, not the quote agent. Production IQ is blocked by a missing Search query role. The original approved native red-team scan failed before scoring. Its approval does not authorize the new protocol shadow. Deferred work: https://github.com/devopsabcs-engineering/foundry-hosted-agents-fsi/issues/49
+Evidence: https://devopsabcs-engineering.github.io/foundry-hosted-agents-fsi/showcase-evidence.html</a:t>
             </a:r>
             <a:endParaRPr lang="en-US" dirty="0"/>
           </a:p>
@@ -1335,6 +1338,98 @@
             <a:fld id="{F7021451-1387-4CA6-816F-3879F97B5CBC}" type="slidenum">
               <a:rPr lang="en-US"/>
               <a:t>18</a:t>
+            </a:fld>
+            <a:endParaRPr lang="en-US"/>
+          </a:p>
+        </p:txBody>
+      </p:sp>
+    </p:spTree>
+    <p:extLst>
+      <p:ext uri="{BB962C8B-B14F-4D97-AF65-F5344CB8AC3E}">
+        <p14:creationId xmlns:p14="http://schemas.microsoft.com/office/powerpoint/2010/main" val="1024086991"/>
+      </p:ext>
+    </p:extLst>
+  </p:cSld>
+  <p:clrMapOvr>
+    <a:masterClrMapping/>
+  </p:clrMapOvr>
+</p:notes>
+</file>
+
+<file path=ppt/notesSlides/notesSlide19.xml><?xml version="1.0" encoding="utf-8"?>
+<p:notes xmlns:a="http://schemas.openxmlformats.org/drawingml/2006/main" xmlns:r="http://schemas.openxmlformats.org/officeDocument/2006/relationships" xmlns:p="http://schemas.openxmlformats.org/presentationml/2006/main">
+  <p:cSld>
+    <p:spTree>
+      <p:nvGrpSpPr>
+        <p:cNvPr id="1" name=""/>
+        <p:cNvGrpSpPr/>
+        <p:nvPr/>
+      </p:nvGrpSpPr>
+      <p:grpSpPr>
+        <a:xfrm>
+          <a:off x="0" y="0"/>
+          <a:ext cx="0" cy="0"/>
+          <a:chOff x="0" y="0"/>
+          <a:chExt cx="0" cy="0"/>
+        </a:xfrm>
+      </p:grpSpPr>
+      <p:sp>
+        <p:nvSpPr>
+          <p:cNvPr id="2" name="Slide Image Placeholder 1"/>
+          <p:cNvSpPr>
+            <a:spLocks noGrp="1" noRot="1" noChangeAspect="1"/>
+          </p:cNvSpPr>
+          <p:nvPr>
+            <p:ph type="sldImg"/>
+          </p:nvPr>
+        </p:nvSpPr>
+        <p:spPr/>
+      </p:sp>
+      <p:sp>
+        <p:nvSpPr>
+          <p:cNvPr id="3" name="Notes Placeholder 2"/>
+          <p:cNvSpPr>
+            <a:spLocks noGrp="1"/>
+          </p:cNvSpPr>
+          <p:nvPr>
+            <p:ph type="body" idx="1"/>
+          </p:nvPr>
+        </p:nvSpPr>
+        <p:spPr/>
+        <p:txBody>
+          <a:bodyPr/>
+          <a:lstStyle/>
+          <a:p>
+            <a:r>
+              <a:rPr lang="en-US" dirty="0"/>
+              <a:t>Allow 3-4 hours for ten exercises. The practice rows are authored synthetic controls, not captured agent responses. Retained screenshots prove only their identified run.
+Guide: https://devopsabcs-engineering.github.io/foundry-hosted-agents-fsi/evaluation-guide.html
+Lab: https://devopsabcs-engineering.github.io/foundry-hosted-agents-fsi/labs/lab-19-evaluation-engineering
+Dataset: https://devopsabcs-engineering.github.io/foundry-hosted-agents-fsi/assets/datasets/portal-practice-en-CA.jsonl
+Deck: https://devopsabcs-engineering.github.io/foundry-hosted-agents-fsi/assets/decks/foundry-evaluation-engineering-en.pptx</a:t>
+            </a:r>
+            <a:endParaRPr lang="en-US" dirty="0"/>
+          </a:p>
+        </p:txBody>
+      </p:sp>
+      <p:sp>
+        <p:nvSpPr>
+          <p:cNvPr id="4" name="Slide Number Placeholder 3"/>
+          <p:cNvSpPr>
+            <a:spLocks noGrp="1"/>
+          </p:cNvSpPr>
+          <p:nvPr>
+            <p:ph type="sldNum" sz="quarter" idx="10"/>
+          </p:nvPr>
+        </p:nvSpPr>
+        <p:spPr/>
+        <p:txBody>
+          <a:bodyPr/>
+          <a:lstStyle/>
+          <a:p>
+            <a:fld id="{F7021451-1387-4CA6-816F-3879F97B5CBC}" type="slidenum">
+              <a:rPr lang="en-US"/>
+              <a:t>19</a:t>
             </a:fld>
             <a:endParaRPr lang="en-US"/>
           </a:p>
@@ -1423,6 +1518,94 @@
             <a:fld id="{F7021451-1387-4CA6-816F-3879F97B5CBC}" type="slidenum">
               <a:rPr lang="en-US"/>
               <a:t>2</a:t>
+            </a:fld>
+            <a:endParaRPr lang="en-US"/>
+          </a:p>
+        </p:txBody>
+      </p:sp>
+    </p:spTree>
+    <p:extLst>
+      <p:ext uri="{BB962C8B-B14F-4D97-AF65-F5344CB8AC3E}">
+        <p14:creationId xmlns:p14="http://schemas.microsoft.com/office/powerpoint/2010/main" val="1024086991"/>
+      </p:ext>
+    </p:extLst>
+  </p:cSld>
+  <p:clrMapOvr>
+    <a:masterClrMapping/>
+  </p:clrMapOvr>
+</p:notes>
+</file>
+
+<file path=ppt/notesSlides/notesSlide20.xml><?xml version="1.0" encoding="utf-8"?>
+<p:notes xmlns:a="http://schemas.openxmlformats.org/drawingml/2006/main" xmlns:r="http://schemas.openxmlformats.org/officeDocument/2006/relationships" xmlns:p="http://schemas.openxmlformats.org/presentationml/2006/main">
+  <p:cSld>
+    <p:spTree>
+      <p:nvGrpSpPr>
+        <p:cNvPr id="1" name=""/>
+        <p:cNvGrpSpPr/>
+        <p:nvPr/>
+      </p:nvGrpSpPr>
+      <p:grpSpPr>
+        <a:xfrm>
+          <a:off x="0" y="0"/>
+          <a:ext cx="0" cy="0"/>
+          <a:chOff x="0" y="0"/>
+          <a:chExt cx="0" cy="0"/>
+        </a:xfrm>
+      </p:grpSpPr>
+      <p:sp>
+        <p:nvSpPr>
+          <p:cNvPr id="2" name="Slide Image Placeholder 1"/>
+          <p:cNvSpPr>
+            <a:spLocks noGrp="1" noRot="1" noChangeAspect="1"/>
+          </p:cNvSpPr>
+          <p:nvPr>
+            <p:ph type="sldImg"/>
+          </p:nvPr>
+        </p:nvSpPr>
+        <p:spPr/>
+      </p:sp>
+      <p:sp>
+        <p:nvSpPr>
+          <p:cNvPr id="3" name="Notes Placeholder 2"/>
+          <p:cNvSpPr>
+            <a:spLocks noGrp="1"/>
+          </p:cNvSpPr>
+          <p:nvPr>
+            <p:ph type="body" idx="1"/>
+          </p:nvPr>
+        </p:nvSpPr>
+        <p:spPr/>
+        <p:txBody>
+          <a:bodyPr/>
+          <a:lstStyle/>
+          <a:p>
+            <a:r>
+              <a:rPr lang="en-US" dirty="0"/>
+              <a:t/>
+            </a:r>
+            <a:endParaRPr lang="en-US" dirty="0"/>
+          </a:p>
+        </p:txBody>
+      </p:sp>
+      <p:sp>
+        <p:nvSpPr>
+          <p:cNvPr id="4" name="Slide Number Placeholder 3"/>
+          <p:cNvSpPr>
+            <a:spLocks noGrp="1"/>
+          </p:cNvSpPr>
+          <p:nvPr>
+            <p:ph type="sldNum" sz="quarter" idx="10"/>
+          </p:nvPr>
+        </p:nvSpPr>
+        <p:spPr/>
+        <p:txBody>
+          <a:bodyPr/>
+          <a:lstStyle/>
+          <a:p>
+            <a:fld id="{F7021451-1387-4CA6-816F-3879F97B5CBC}" type="slidenum">
+              <a:rPr lang="en-US"/>
+              <a:t>20</a:t>
             </a:fld>
             <a:endParaRPr lang="en-US"/>
           </a:p>
@@ -2496,7 +2679,7 @@
                   <a:srgbClr val="767676"/>
                 </a:solidFill>
               </a:rPr>
-              <a:t>1 / 18</a:t>
+              <a:t>1 / 20</a:t>
             </a:r>
             <a:endParaRPr lang="en-US" sz="900" dirty="0"/>
           </a:p>
@@ -2847,7 +3030,7 @@
                   <a:srgbClr val="767676"/>
                 </a:solidFill>
               </a:rPr>
-              <a:t>10 / 18</a:t>
+              <a:t>10 / 20</a:t>
             </a:r>
             <a:endParaRPr lang="en-US" sz="900" dirty="0"/>
           </a:p>
@@ -3198,7 +3381,7 @@
                   <a:srgbClr val="767676"/>
                 </a:solidFill>
               </a:rPr>
-              <a:t>11 / 18</a:t>
+              <a:t>11 / 20</a:t>
             </a:r>
             <a:endParaRPr lang="en-US" sz="900" dirty="0"/>
           </a:p>
@@ -3549,7 +3732,7 @@
                   <a:srgbClr val="767676"/>
                 </a:solidFill>
               </a:rPr>
-              <a:t>12 / 18</a:t>
+              <a:t>12 / 20</a:t>
             </a:r>
             <a:endParaRPr lang="en-US" sz="900" dirty="0"/>
           </a:p>
@@ -3900,7 +4083,7 @@
                   <a:srgbClr val="767676"/>
                 </a:solidFill>
               </a:rPr>
-              <a:t>13 / 18</a:t>
+              <a:t>13 / 20</a:t>
             </a:r>
             <a:endParaRPr lang="en-US" sz="900" dirty="0"/>
           </a:p>
@@ -4251,7 +4434,7 @@
                   <a:srgbClr val="767676"/>
                 </a:solidFill>
               </a:rPr>
-              <a:t>14 / 18</a:t>
+              <a:t>14 / 20</a:t>
             </a:r>
             <a:endParaRPr lang="en-US" sz="900" dirty="0"/>
           </a:p>
@@ -4602,7 +4785,7 @@
                   <a:srgbClr val="767676"/>
                 </a:solidFill>
               </a:rPr>
-              <a:t>15 / 18</a:t>
+              <a:t>15 / 20</a:t>
             </a:r>
             <a:endParaRPr lang="en-US" sz="900" dirty="0"/>
           </a:p>
@@ -4858,7 +5041,7 @@
                 <a:ea typeface="Segoe UI" pitchFamily="34" charset="-122"/>
                 <a:cs typeface="Segoe UI" pitchFamily="34" charset="-120"/>
               </a:rPr>
-              <a:t>Review the exact prohibited-actions taxonomy before a bounded native red-team run</a:t>
+              <a:t>Approved native red-team scan failed before scoring; this is not a safety pass</a:t>
             </a:r>
             <a:endParaRPr lang="en-US" sz="1500" dirty="0"/>
           </a:p>
@@ -4974,7 +5157,7 @@
                   <a:srgbClr val="767676"/>
                 </a:solidFill>
               </a:rPr>
-              <a:t>16 / 18</a:t>
+              <a:t>16 / 20</a:t>
             </a:r>
             <a:endParaRPr lang="en-US" sz="900" dirty="0"/>
           </a:p>
@@ -5325,7 +5508,7 @@
                   <a:srgbClr val="767676"/>
                 </a:solidFill>
               </a:rPr>
-              <a:t>17 / 18</a:t>
+              <a:t>17 / 20</a:t>
             </a:r>
             <a:endParaRPr lang="en-US" sz="900" dirty="0"/>
           </a:p>
@@ -5416,7 +5599,7 @@
                 <a:ea typeface="Segoe UI" pitchFamily="34" charset="-122"/>
                 <a:cs typeface="Segoe UI" pitchFamily="34" charset="-120"/>
               </a:rPr>
-              <a:t>WRAP-UP</a:t>
+              <a:t>SESSION 2 / CURRENT EVIDENCE</a:t>
             </a:r>
             <a:endParaRPr lang="en-US" sz="1100" dirty="0"/>
           </a:p>
@@ -5455,7 +5638,7 @@
                 <a:ea typeface="Segoe UI" pitchFamily="34" charset="-122"/>
                 <a:cs typeface="Segoe UI" pitchFamily="34" charset="-120"/>
               </a:rPr>
-              <a:t>A Retained, Synthetic Customer Demo</a:t>
+              <a:t>Verified and Deferred Are Different</a:t>
             </a:r>
             <a:endParaRPr lang="en-US" sz="2600" dirty="0"/>
           </a:p>
@@ -5518,7 +5701,7 @@
                 <a:ea typeface="Segoe UI" pitchFamily="34" charset="-122"/>
                 <a:cs typeface="Segoe UI" pitchFamily="34" charset="-120"/>
               </a:rPr>
-              <a:t>Every fixture, rulebook, and calculator output is synthetic and non-binding</a:t>
+              <a:t>Retained quote release: staging v6 and production v7; documentation does not redeploy it</a:t>
             </a:r>
             <a:endParaRPr lang="en-US" sz="1500" dirty="0"/>
           </a:p>
@@ -5539,7 +5722,7 @@
                 <a:ea typeface="Segoe UI" pitchFamily="34" charset="-122"/>
                 <a:cs typeface="Segoe UI" pitchFamily="34" charset="-120"/>
               </a:rPr>
-              <a:t>Staging and production are restored; enhancements require separate measured live acceptance</a:t>
+              <a:t>Isolated staging IQ companion v2: 8/8 bilingual checks; production remains unpromoted</a:t>
             </a:r>
             <a:endParaRPr lang="en-US" sz="1500" dirty="0"/>
           </a:p>
@@ -5560,7 +5743,7 @@
                 <a:ea typeface="Segoe UI" pitchFamily="34" charset="-122"/>
                 <a:cs typeface="Segoe UI" pitchFamily="34" charset="-120"/>
               </a:rPr>
-              <a:t>A human reviewer, never the agent, decides whether a draft can reach the applicant</a:t>
+              <a:t>Native Content Understanding invoice extraction passed in staging and production</a:t>
             </a:r>
             <a:endParaRPr lang="en-US" sz="1500" dirty="0"/>
           </a:p>
@@ -5581,7 +5764,7 @@
                 <a:ea typeface="Segoe UI" pitchFamily="34" charset="-122"/>
                 <a:cs typeface="Segoe UI" pitchFamily="34" charset="-120"/>
               </a:rPr>
-              <a:t>Full bilingual step-by-step labs: this deck’s companion GitHub Pages site</a:t>
+              <a:t>Protocol-only red-team shadow passes offline tests, not native acceptance or scan approval</a:t>
             </a:r>
             <a:endParaRPr lang="en-US" sz="1500" dirty="0"/>
           </a:p>
@@ -5648,7 +5831,7 @@
       </p:sp>
       <p:sp>
         <p:nvSpPr>
-          <p:cNvPr id="9" name="Text 7"/>
+          <p:cNvPr id="10" name="Text 7"/>
           <p:cNvSpPr/>
           <p:nvPr/>
         </p:nvSpPr>
@@ -5676,7 +5859,358 @@
                   <a:srgbClr val="767676"/>
                 </a:solidFill>
               </a:rPr>
-              <a:t>18 / 18</a:t>
+              <a:t>18 / 20</a:t>
+            </a:r>
+            <a:endParaRPr lang="en-US" sz="900" dirty="0"/>
+          </a:p>
+        </p:txBody>
+      </p:sp>
+    </p:spTree>
+  </p:cSld>
+  <p:clrMapOvr>
+    <a:masterClrMapping/>
+  </p:clrMapOvr>
+</p:sld>
+</file>
+
+<file path=ppt/slides/slide19.xml><?xml version="1.0" encoding="utf-8"?>
+<p:sld xmlns:a="http://schemas.openxmlformats.org/drawingml/2006/main" xmlns:r="http://schemas.openxmlformats.org/officeDocument/2006/relationships" xmlns:p="http://schemas.openxmlformats.org/presentationml/2006/main">
+  <p:cSld name="Slide 19">
+    <p:bg>
+      <p:bgPr>
+        <a:solidFill>
+          <a:srgbClr val="FAFBFC"/>
+        </a:solidFill>
+      </p:bgPr>
+    </p:bg>
+    <p:spTree>
+      <p:nvGrpSpPr>
+        <p:cNvPr id="1" name=""/>
+        <p:cNvGrpSpPr/>
+        <p:nvPr/>
+      </p:nvGrpSpPr>
+      <p:grpSpPr>
+        <a:xfrm>
+          <a:off x="0" y="0"/>
+          <a:ext cx="0" cy="0"/>
+          <a:chOff x="0" y="0"/>
+          <a:chExt cx="0" cy="0"/>
+        </a:xfrm>
+      </p:grpSpPr>
+      <p:sp>
+        <p:nvSpPr>
+          <p:cNvPr id="2" name="Shape 0"/>
+          <p:cNvSpPr/>
+          <p:nvPr/>
+        </p:nvSpPr>
+        <p:spPr>
+          <a:xfrm>
+            <a:off x="0" y="0"/>
+            <a:ext cx="12188952" cy="82296"/>
+          </a:xfrm>
+          <a:prstGeom prst="rect">
+            <a:avLst/>
+          </a:prstGeom>
+          <a:solidFill>
+            <a:srgbClr val="0078D4"/>
+          </a:solidFill>
+          <a:ln/>
+        </p:spPr>
+      </p:sp>
+      <p:sp>
+        <p:nvSpPr>
+          <p:cNvPr id="3" name="Text 1"/>
+          <p:cNvSpPr/>
+          <p:nvPr/>
+        </p:nvSpPr>
+        <p:spPr>
+          <a:xfrm>
+            <a:off x="457200" y="292608"/>
+            <a:ext cx="11247120" cy="274320"/>
+          </a:xfrm>
+          <a:prstGeom prst="rect">
+            <a:avLst/>
+          </a:prstGeom>
+          <a:noFill/>
+          <a:ln/>
+        </p:spPr>
+        <p:txBody>
+          <a:bodyPr wrap="square" rtlCol="0" anchor="ctr"/>
+          <a:lstStyle/>
+          <a:p>
+            <a:pPr indent="0" marL="0">
+              <a:buNone/>
+            </a:pPr>
+            <a:r>
+              <a:rPr lang="en-US" sz="1100" b="1" spc="100" kern="0" dirty="0">
+                <a:solidFill>
+                  <a:srgbClr val="0078D4"/>
+                </a:solidFill>
+                <a:latin typeface="Segoe UI" pitchFamily="34" charset="0"/>
+                <a:ea typeface="Segoe UI" pitchFamily="34" charset="-122"/>
+                <a:cs typeface="Segoe UI" pitchFamily="34" charset="-120"/>
+              </a:rPr>
+              <a:t>LAB 19 / EVALUATION ENGINEERING</a:t>
+            </a:r>
+            <a:endParaRPr lang="en-US" sz="1100" dirty="0"/>
+          </a:p>
+        </p:txBody>
+      </p:sp>
+      <p:sp>
+        <p:nvSpPr>
+          <p:cNvPr id="4" name="Text 2"/>
+          <p:cNvSpPr/>
+          <p:nvPr/>
+        </p:nvSpPr>
+        <p:spPr>
+          <a:xfrm>
+            <a:off x="457200" y="548640"/>
+            <a:ext cx="11247120" cy="640080"/>
+          </a:xfrm>
+          <a:prstGeom prst="rect">
+            <a:avLst/>
+          </a:prstGeom>
+          <a:noFill/>
+          <a:ln/>
+        </p:spPr>
+        <p:txBody>
+          <a:bodyPr wrap="square" rtlCol="0" anchor="ctr"/>
+          <a:lstStyle/>
+          <a:p>
+            <a:pPr indent="0" marL="0">
+              <a:buNone/>
+            </a:pPr>
+            <a:r>
+              <a:rPr lang="en-US" sz="2600" b="1" dirty="0">
+                <a:solidFill>
+                  <a:srgbClr val="001B3D"/>
+                </a:solidFill>
+                <a:latin typeface="Segoe UI" pitchFamily="34" charset="0"/>
+                <a:ea typeface="Segoe UI" pitchFamily="34" charset="-122"/>
+                <a:cs typeface="Segoe UI" pitchFamily="34" charset="-120"/>
+              </a:rPr>
+              <a:t>Continue with the Evaluation Deep Lab</a:t>
+            </a:r>
+            <a:endParaRPr lang="en-US" sz="2600" dirty="0"/>
+          </a:p>
+        </p:txBody>
+      </p:sp>
+      <p:sp>
+        <p:nvSpPr>
+          <p:cNvPr id="5" name="Shape 3"/>
+          <p:cNvSpPr/>
+          <p:nvPr/>
+        </p:nvSpPr>
+        <p:spPr>
+          <a:xfrm>
+            <a:off x="457200" y="1188720"/>
+            <a:ext cx="11247120" cy="10973"/>
+          </a:xfrm>
+          <a:prstGeom prst="rect">
+            <a:avLst/>
+          </a:prstGeom>
+          <a:solidFill>
+            <a:srgbClr val="E1E5E8"/>
+          </a:solidFill>
+          <a:ln/>
+        </p:spPr>
+      </p:sp>
+      <p:sp>
+        <p:nvSpPr>
+          <p:cNvPr id="6" name="Text 4"/>
+          <p:cNvSpPr/>
+          <p:nvPr/>
+        </p:nvSpPr>
+        <p:spPr>
+          <a:xfrm>
+            <a:off x="548640" y="1463040"/>
+            <a:ext cx="11064240" cy="5029200"/>
+          </a:xfrm>
+          <a:prstGeom prst="rect">
+            <a:avLst/>
+          </a:prstGeom>
+          <a:noFill/>
+          <a:ln/>
+        </p:spPr>
+        <p:txBody>
+          <a:bodyPr wrap="square" rtlCol="0" anchor="t"/>
+          <a:lstStyle/>
+          <a:p>
+            <a:pPr marL="254000" indent="-254000">
+              <a:lnSpc>
+                <a:spcPct val="125000"/>
+              </a:lnSpc>
+              <a:buSzPct val="100000"/>
+              <a:buChar char="●"/>
+            </a:pPr>
+            <a:r>
+              <a:rPr lang="en-US" sz="1500" dirty="0">
+                <a:solidFill>
+                  <a:srgbClr val="1A1A1A"/>
+                </a:solidFill>
+                <a:latin typeface="Segoe UI" pitchFamily="34" charset="0"/>
+                <a:ea typeface="Segoe UI" pitchFamily="34" charset="-122"/>
+                <a:cs typeface="Segoe UI" pitchFamily="34" charset="-120"/>
+              </a:rPr>
+              <a:t>Complete curriculum: local Labs 00-09, pilot 10-14, native 15-18 and evaluation Lab 19</a:t>
+            </a:r>
+            <a:endParaRPr lang="en-US" sz="1500" dirty="0"/>
+          </a:p>
+          <a:p>
+            <a:pPr marL="254000" indent="-254000">
+              <a:lnSpc>
+                <a:spcPct val="125000"/>
+              </a:lnSpc>
+              <a:buSzPct val="100000"/>
+              <a:buChar char="●"/>
+            </a:pPr>
+            <a:r>
+              <a:rPr lang="en-US" sz="1500" dirty="0">
+                <a:solidFill>
+                  <a:srgbClr val="1A1A1A"/>
+                </a:solidFill>
+                <a:latin typeface="Segoe UI" pitchFamily="34" charset="0"/>
+                <a:ea typeface="Segoe UI" pitchFamily="34" charset="-122"/>
+                <a:cs typeface="Segoe UI" pitchFamily="34" charset="-120"/>
+              </a:rPr>
+              <a:t>Read-only portal walkthrough: overview, detailed results and three built-in evaluator captures</a:t>
+            </a:r>
+            <a:endParaRPr lang="en-US" sz="1500" dirty="0"/>
+          </a:p>
+          <a:p>
+            <a:pPr marL="254000" indent="-254000">
+              <a:lnSpc>
+                <a:spcPct val="125000"/>
+              </a:lnSpc>
+              <a:buSzPct val="100000"/>
+              <a:buChar char="●"/>
+            </a:pPr>
+            <a:r>
+              <a:rPr lang="en-US" sz="1500" dirty="0">
+                <a:solidFill>
+                  <a:srgbClr val="1A1A1A"/>
+                </a:solidFill>
+                <a:latin typeface="Segoe UI" pitchFamily="34" charset="0"/>
+                <a:ea typeface="Segoe UI" pitchFamily="34" charset="-122"/>
+                <a:cs typeface="Segoe UI" pitchFamily="34" charset="-120"/>
+              </a:rPr>
+              <a:t>Use supplied EN/FR synthetic JSONL controls; uploads and paid submissions need approval</a:t>
+            </a:r>
+            <a:endParaRPr lang="en-US" sz="1500" dirty="0"/>
+          </a:p>
+          <a:p>
+            <a:pPr marL="254000" indent="-254000">
+              <a:lnSpc>
+                <a:spcPct val="125000"/>
+              </a:lnSpc>
+              <a:buSzPct val="100000"/>
+              <a:buChar char="●"/>
+            </a:pPr>
+            <a:r>
+              <a:rPr lang="en-US" sz="1500" dirty="0">
+                <a:solidFill>
+                  <a:srgbClr val="1A1A1A"/>
+                </a:solidFill>
+                <a:latin typeface="Segoe UI" pitchFamily="34" charset="0"/>
+                <a:ea typeface="Segoe UI" pitchFamily="34" charset="-122"/>
+                <a:cs typeface="Segoe UI" pitchFamily="34" charset="-120"/>
+              </a:rPr>
+              <a:t>Dedicated evaluation decks: 37 editable slides per language, with instructor notes</a:t>
+            </a:r>
+            <a:endParaRPr lang="en-US" sz="1500" dirty="0"/>
+          </a:p>
+        </p:txBody>
+      </p:sp>
+      <p:sp>
+        <p:nvSpPr>
+          <p:cNvPr id="7" name="Shape 5"/>
+          <p:cNvSpPr/>
+          <p:nvPr/>
+        </p:nvSpPr>
+        <p:spPr>
+          <a:xfrm>
+            <a:off x="0" y="6784848"/>
+            <a:ext cx="12188952" cy="27432"/>
+          </a:xfrm>
+          <a:prstGeom prst="rect">
+            <a:avLst/>
+          </a:prstGeom>
+          <a:solidFill>
+            <a:srgbClr val="E1E5E8"/>
+          </a:solidFill>
+          <a:ln/>
+        </p:spPr>
+      </p:sp>
+      <p:sp>
+        <p:nvSpPr>
+          <p:cNvPr id="8" name="Text 6"/>
+          <p:cNvSpPr/>
+          <p:nvPr/>
+        </p:nvSpPr>
+        <p:spPr>
+          <a:xfrm>
+            <a:off x="457200" y="6537960"/>
+            <a:ext cx="8229600" cy="256032"/>
+          </a:xfrm>
+          <a:prstGeom prst="rect">
+            <a:avLst/>
+          </a:prstGeom>
+          <a:noFill/>
+          <a:ln/>
+        </p:spPr>
+        <p:txBody>
+          <a:bodyPr wrap="square" rtlCol="0" anchor="ctr"/>
+          <a:lstStyle/>
+          <a:p>
+            <a:pPr indent="0" marL="0">
+              <a:buNone/>
+            </a:pPr>
+            <a:r>
+              <a:rPr lang="en-US" sz="900" dirty="0">
+                <a:solidFill>
+                  <a:srgbClr val="767676"/>
+                </a:solidFill>
+                <a:latin typeface="Segoe UI" pitchFamily="34" charset="0"/>
+                <a:ea typeface="Segoe UI" pitchFamily="34" charset="-122"/>
+                <a:cs typeface="Segoe UI" pitchFamily="34" charset="-120"/>
+              </a:rPr>
+              <a:t>Desjardins Bilingual Hosted Agents Workshop</a:t>
+            </a:r>
+            <a:endParaRPr lang="en-US" sz="900" dirty="0"/>
+          </a:p>
+        </p:txBody>
+      </p:sp>
+      <p:sp>
+        <p:nvSpPr>
+          <p:cNvPr id="10" name="Text 7"/>
+          <p:cNvSpPr/>
+          <p:nvPr/>
+        </p:nvSpPr>
+        <p:spPr>
+          <a:xfrm>
+            <a:off x="11338560" y="6528816"/>
+            <a:ext cx="548640" cy="219456"/>
+          </a:xfrm>
+          <a:prstGeom prst="rect">
+            <a:avLst/>
+          </a:prstGeom>
+          <a:noFill/>
+          <a:ln/>
+        </p:spPr>
+        <p:txBody>
+          <a:bodyPr wrap="square" rtlCol="0" anchor="ctr"/>
+          <a:lstStyle/>
+          <a:p>
+            <a:pPr algn="r" indent="0" marL="0">
+              <a:buNone/>
+            </a:pPr>
+            <a:r>
+              <a:rPr lang="en-US" sz="900" dirty="0">
+                <a:solidFill>
+                  <a:srgbClr val="767676"/>
+                </a:solidFill>
+              </a:rPr>
+              <a:t>19 / 20</a:t>
             </a:r>
             <a:endParaRPr lang="en-US" sz="900" dirty="0"/>
           </a:p>
@@ -6062,6 +6596,69 @@
             </a:r>
             <a:endParaRPr lang="en-US" sz="1500" dirty="0"/>
           </a:p>
+          <a:p>
+            <a:pPr marL="254000" indent="-254000">
+              <a:lnSpc>
+                <a:spcPct val="125000"/>
+              </a:lnSpc>
+              <a:buSzPct val="100000"/>
+              <a:buChar char="●"/>
+            </a:pPr>
+            <a:r>
+              <a:rPr lang="en-US" sz="1500" dirty="0">
+                <a:solidFill>
+                  <a:srgbClr val="1A1A1A"/>
+                </a:solidFill>
+                <a:latin typeface="Segoe UI" pitchFamily="34" charset="0"/>
+                <a:ea typeface="Segoe UI" pitchFamily="34" charset="-122"/>
+                <a:cs typeface="Segoe UI" pitchFamily="34" charset="-120"/>
+              </a:rPr>
+              <a:t>Labs 10-14: controlled pilot surfaces</a:t>
+            </a:r>
+            <a:endParaRPr lang="en-US" sz="1500" dirty="0"/>
+          </a:p>
+          <a:p>
+            <a:pPr marL="254000" indent="-254000">
+              <a:lnSpc>
+                <a:spcPct val="125000"/>
+              </a:lnSpc>
+              <a:buSzPct val="100000"/>
+              <a:buChar char="●"/>
+            </a:pPr>
+            <a:r>
+              <a:rPr lang="en-US" sz="1500" dirty="0">
+                <a:solidFill>
+                  <a:srgbClr val="1A1A1A"/>
+                </a:solidFill>
+                <a:latin typeface="Segoe UI" pitchFamily="34" charset="0"/>
+                <a:ea typeface="Segoe UI" pitchFamily="34" charset="-122"/>
+                <a:cs typeface="Segoe UI" pitchFamily="34" charset="-120"/>
+              </a:rPr>
+              <a:t>Labs 15-18: isolated native showcase</a:t>
+            </a:r>
+            <a:endParaRPr lang="en-US" sz="1500" dirty="0"/>
+          </a:p>
+          <a:p>
+            <a:pPr marL="254000" indent="-254000">
+              <a:lnSpc>
+                <a:spcPct val="125000"/>
+              </a:lnSpc>
+              <a:buSzPct val="100000"/>
+              <a:buChar char="●"/>
+            </a:pPr>
+            <a:r>
+              <a:rPr lang="en-US" sz="1500" dirty="0">
+                <a:solidFill>
+                  <a:srgbClr val="1A1A1A"/>
+                </a:solidFill>
+                <a:latin typeface="Segoe UI" pitchFamily="34" charset="0"/>
+                <a:ea typeface="Segoe UI" pitchFamily="34" charset="-122"/>
+                <a:cs typeface="Segoe UI" pitchFamily="34" charset="-120"/>
+              </a:rPr>
+              <a:t>Lab 19: evaluation engineering deep lab</a:t>
+            </a:r>
+            <a:endParaRPr lang="en-US" sz="1500" dirty="0"/>
+          </a:p>
         </p:txBody>
       </p:sp>
       <p:sp>
@@ -6153,7 +6750,358 @@
                   <a:srgbClr val="767676"/>
                 </a:solidFill>
               </a:rPr>
-              <a:t>2 / 18</a:t>
+              <a:t>2 / 20</a:t>
+            </a:r>
+            <a:endParaRPr lang="en-US" sz="900" dirty="0"/>
+          </a:p>
+        </p:txBody>
+      </p:sp>
+    </p:spTree>
+  </p:cSld>
+  <p:clrMapOvr>
+    <a:masterClrMapping/>
+  </p:clrMapOvr>
+</p:sld>
+</file>
+
+<file path=ppt/slides/slide20.xml><?xml version="1.0" encoding="utf-8"?>
+<p:sld xmlns:a="http://schemas.openxmlformats.org/drawingml/2006/main" xmlns:r="http://schemas.openxmlformats.org/officeDocument/2006/relationships" xmlns:p="http://schemas.openxmlformats.org/presentationml/2006/main">
+  <p:cSld name="Slide 20">
+    <p:bg>
+      <p:bgPr>
+        <a:solidFill>
+          <a:srgbClr val="FAFBFC"/>
+        </a:solidFill>
+      </p:bgPr>
+    </p:bg>
+    <p:spTree>
+      <p:nvGrpSpPr>
+        <p:cNvPr id="1" name=""/>
+        <p:cNvGrpSpPr/>
+        <p:nvPr/>
+      </p:nvGrpSpPr>
+      <p:grpSpPr>
+        <a:xfrm>
+          <a:off x="0" y="0"/>
+          <a:ext cx="0" cy="0"/>
+          <a:chOff x="0" y="0"/>
+          <a:chExt cx="0" cy="0"/>
+        </a:xfrm>
+      </p:grpSpPr>
+      <p:sp>
+        <p:nvSpPr>
+          <p:cNvPr id="2" name="Shape 0"/>
+          <p:cNvSpPr/>
+          <p:nvPr/>
+        </p:nvSpPr>
+        <p:spPr>
+          <a:xfrm>
+            <a:off x="0" y="0"/>
+            <a:ext cx="12188952" cy="82296"/>
+          </a:xfrm>
+          <a:prstGeom prst="rect">
+            <a:avLst/>
+          </a:prstGeom>
+          <a:solidFill>
+            <a:srgbClr val="0078D4"/>
+          </a:solidFill>
+          <a:ln/>
+        </p:spPr>
+      </p:sp>
+      <p:sp>
+        <p:nvSpPr>
+          <p:cNvPr id="3" name="Text 1"/>
+          <p:cNvSpPr/>
+          <p:nvPr/>
+        </p:nvSpPr>
+        <p:spPr>
+          <a:xfrm>
+            <a:off x="457200" y="292608"/>
+            <a:ext cx="11247120" cy="274320"/>
+          </a:xfrm>
+          <a:prstGeom prst="rect">
+            <a:avLst/>
+          </a:prstGeom>
+          <a:noFill/>
+          <a:ln/>
+        </p:spPr>
+        <p:txBody>
+          <a:bodyPr wrap="square" rtlCol="0" anchor="ctr"/>
+          <a:lstStyle/>
+          <a:p>
+            <a:pPr indent="0" marL="0">
+              <a:buNone/>
+            </a:pPr>
+            <a:r>
+              <a:rPr lang="en-US" sz="1100" b="1" spc="100" kern="0" dirty="0">
+                <a:solidFill>
+                  <a:srgbClr val="0078D4"/>
+                </a:solidFill>
+                <a:latin typeface="Segoe UI" pitchFamily="34" charset="0"/>
+                <a:ea typeface="Segoe UI" pitchFamily="34" charset="-122"/>
+                <a:cs typeface="Segoe UI" pitchFamily="34" charset="-120"/>
+              </a:rPr>
+              <a:t>WRAP-UP</a:t>
+            </a:r>
+            <a:endParaRPr lang="en-US" sz="1100" dirty="0"/>
+          </a:p>
+        </p:txBody>
+      </p:sp>
+      <p:sp>
+        <p:nvSpPr>
+          <p:cNvPr id="4" name="Text 2"/>
+          <p:cNvSpPr/>
+          <p:nvPr/>
+        </p:nvSpPr>
+        <p:spPr>
+          <a:xfrm>
+            <a:off x="457200" y="548640"/>
+            <a:ext cx="11247120" cy="640080"/>
+          </a:xfrm>
+          <a:prstGeom prst="rect">
+            <a:avLst/>
+          </a:prstGeom>
+          <a:noFill/>
+          <a:ln/>
+        </p:spPr>
+        <p:txBody>
+          <a:bodyPr wrap="square" rtlCol="0" anchor="ctr"/>
+          <a:lstStyle/>
+          <a:p>
+            <a:pPr indent="0" marL="0">
+              <a:buNone/>
+            </a:pPr>
+            <a:r>
+              <a:rPr lang="en-US" sz="2600" b="1" dirty="0">
+                <a:solidFill>
+                  <a:srgbClr val="001B3D"/>
+                </a:solidFill>
+                <a:latin typeface="Segoe UI" pitchFamily="34" charset="0"/>
+                <a:ea typeface="Segoe UI" pitchFamily="34" charset="-122"/>
+                <a:cs typeface="Segoe UI" pitchFamily="34" charset="-120"/>
+              </a:rPr>
+              <a:t>A Retained, Synthetic Customer Demo</a:t>
+            </a:r>
+            <a:endParaRPr lang="en-US" sz="2600" dirty="0"/>
+          </a:p>
+        </p:txBody>
+      </p:sp>
+      <p:sp>
+        <p:nvSpPr>
+          <p:cNvPr id="5" name="Shape 3"/>
+          <p:cNvSpPr/>
+          <p:nvPr/>
+        </p:nvSpPr>
+        <p:spPr>
+          <a:xfrm>
+            <a:off x="457200" y="1188720"/>
+            <a:ext cx="11247120" cy="10973"/>
+          </a:xfrm>
+          <a:prstGeom prst="rect">
+            <a:avLst/>
+          </a:prstGeom>
+          <a:solidFill>
+            <a:srgbClr val="E1E5E8"/>
+          </a:solidFill>
+          <a:ln/>
+        </p:spPr>
+      </p:sp>
+      <p:sp>
+        <p:nvSpPr>
+          <p:cNvPr id="6" name="Text 4"/>
+          <p:cNvSpPr/>
+          <p:nvPr/>
+        </p:nvSpPr>
+        <p:spPr>
+          <a:xfrm>
+            <a:off x="548640" y="1463040"/>
+            <a:ext cx="11064240" cy="5029200"/>
+          </a:xfrm>
+          <a:prstGeom prst="rect">
+            <a:avLst/>
+          </a:prstGeom>
+          <a:noFill/>
+          <a:ln/>
+        </p:spPr>
+        <p:txBody>
+          <a:bodyPr wrap="square" rtlCol="0" anchor="t"/>
+          <a:lstStyle/>
+          <a:p>
+            <a:pPr marL="254000" indent="-254000">
+              <a:lnSpc>
+                <a:spcPct val="125000"/>
+              </a:lnSpc>
+              <a:buSzPct val="100000"/>
+              <a:buChar char="●"/>
+            </a:pPr>
+            <a:r>
+              <a:rPr lang="en-US" sz="1500" dirty="0">
+                <a:solidFill>
+                  <a:srgbClr val="1A1A1A"/>
+                </a:solidFill>
+                <a:latin typeface="Segoe UI" pitchFamily="34" charset="0"/>
+                <a:ea typeface="Segoe UI" pitchFamily="34" charset="-122"/>
+                <a:cs typeface="Segoe UI" pitchFamily="34" charset="-120"/>
+              </a:rPr>
+              <a:t>Every fixture, rulebook, and calculator output is synthetic and non-binding</a:t>
+            </a:r>
+            <a:endParaRPr lang="en-US" sz="1500" dirty="0"/>
+          </a:p>
+          <a:p>
+            <a:pPr marL="254000" indent="-254000">
+              <a:lnSpc>
+                <a:spcPct val="125000"/>
+              </a:lnSpc>
+              <a:buSzPct val="100000"/>
+              <a:buChar char="●"/>
+            </a:pPr>
+            <a:r>
+              <a:rPr lang="en-US" sz="1500" dirty="0">
+                <a:solidFill>
+                  <a:srgbClr val="1A1A1A"/>
+                </a:solidFill>
+                <a:latin typeface="Segoe UI" pitchFamily="34" charset="0"/>
+                <a:ea typeface="Segoe UI" pitchFamily="34" charset="-122"/>
+                <a:cs typeface="Segoe UI" pitchFamily="34" charset="-120"/>
+              </a:rPr>
+              <a:t>Staging and production are restored; enhancements require separate measured live acceptance</a:t>
+            </a:r>
+            <a:endParaRPr lang="en-US" sz="1500" dirty="0"/>
+          </a:p>
+          <a:p>
+            <a:pPr marL="254000" indent="-254000">
+              <a:lnSpc>
+                <a:spcPct val="125000"/>
+              </a:lnSpc>
+              <a:buSzPct val="100000"/>
+              <a:buChar char="●"/>
+            </a:pPr>
+            <a:r>
+              <a:rPr lang="en-US" sz="1500" dirty="0">
+                <a:solidFill>
+                  <a:srgbClr val="1A1A1A"/>
+                </a:solidFill>
+                <a:latin typeface="Segoe UI" pitchFamily="34" charset="0"/>
+                <a:ea typeface="Segoe UI" pitchFamily="34" charset="-122"/>
+                <a:cs typeface="Segoe UI" pitchFamily="34" charset="-120"/>
+              </a:rPr>
+              <a:t>A human reviewer, never the agent, decides whether a draft can reach the applicant</a:t>
+            </a:r>
+            <a:endParaRPr lang="en-US" sz="1500" dirty="0"/>
+          </a:p>
+          <a:p>
+            <a:pPr marL="254000" indent="-254000">
+              <a:lnSpc>
+                <a:spcPct val="125000"/>
+              </a:lnSpc>
+              <a:buSzPct val="100000"/>
+              <a:buChar char="●"/>
+            </a:pPr>
+            <a:r>
+              <a:rPr lang="en-US" sz="1500" dirty="0">
+                <a:solidFill>
+                  <a:srgbClr val="1A1A1A"/>
+                </a:solidFill>
+                <a:latin typeface="Segoe UI" pitchFamily="34" charset="0"/>
+                <a:ea typeface="Segoe UI" pitchFamily="34" charset="-122"/>
+                <a:cs typeface="Segoe UI" pitchFamily="34" charset="-120"/>
+              </a:rPr>
+              <a:t>Full bilingual step-by-step labs: this deck’s companion GitHub Pages site</a:t>
+            </a:r>
+            <a:endParaRPr lang="en-US" sz="1500" dirty="0"/>
+          </a:p>
+        </p:txBody>
+      </p:sp>
+      <p:sp>
+        <p:nvSpPr>
+          <p:cNvPr id="7" name="Shape 5"/>
+          <p:cNvSpPr/>
+          <p:nvPr/>
+        </p:nvSpPr>
+        <p:spPr>
+          <a:xfrm>
+            <a:off x="0" y="6784848"/>
+            <a:ext cx="12188952" cy="27432"/>
+          </a:xfrm>
+          <a:prstGeom prst="rect">
+            <a:avLst/>
+          </a:prstGeom>
+          <a:solidFill>
+            <a:srgbClr val="E1E5E8"/>
+          </a:solidFill>
+          <a:ln/>
+        </p:spPr>
+      </p:sp>
+      <p:sp>
+        <p:nvSpPr>
+          <p:cNvPr id="8" name="Text 6"/>
+          <p:cNvSpPr/>
+          <p:nvPr/>
+        </p:nvSpPr>
+        <p:spPr>
+          <a:xfrm>
+            <a:off x="457200" y="6537960"/>
+            <a:ext cx="8229600" cy="256032"/>
+          </a:xfrm>
+          <a:prstGeom prst="rect">
+            <a:avLst/>
+          </a:prstGeom>
+          <a:noFill/>
+          <a:ln/>
+        </p:spPr>
+        <p:txBody>
+          <a:bodyPr wrap="square" rtlCol="0" anchor="ctr"/>
+          <a:lstStyle/>
+          <a:p>
+            <a:pPr indent="0" marL="0">
+              <a:buNone/>
+            </a:pPr>
+            <a:r>
+              <a:rPr lang="en-US" sz="900" dirty="0">
+                <a:solidFill>
+                  <a:srgbClr val="767676"/>
+                </a:solidFill>
+                <a:latin typeface="Segoe UI" pitchFamily="34" charset="0"/>
+                <a:ea typeface="Segoe UI" pitchFamily="34" charset="-122"/>
+                <a:cs typeface="Segoe UI" pitchFamily="34" charset="-120"/>
+              </a:rPr>
+              <a:t>Desjardins Bilingual Hosted Agents Workshop</a:t>
+            </a:r>
+            <a:endParaRPr lang="en-US" sz="900" dirty="0"/>
+          </a:p>
+        </p:txBody>
+      </p:sp>
+      <p:sp>
+        <p:nvSpPr>
+          <p:cNvPr id="9" name="Text 7"/>
+          <p:cNvSpPr/>
+          <p:nvPr/>
+        </p:nvSpPr>
+        <p:spPr>
+          <a:xfrm>
+            <a:off x="11338560" y="6528816"/>
+            <a:ext cx="548640" cy="219456"/>
+          </a:xfrm>
+          <a:prstGeom prst="rect">
+            <a:avLst/>
+          </a:prstGeom>
+          <a:noFill/>
+          <a:ln/>
+        </p:spPr>
+        <p:txBody>
+          <a:bodyPr wrap="square" rtlCol="0" anchor="ctr"/>
+          <a:lstStyle/>
+          <a:p>
+            <a:pPr algn="r" indent="0" marL="0">
+              <a:buNone/>
+            </a:pPr>
+            <a:r>
+              <a:rPr lang="en-US" sz="900" dirty="0">
+                <a:solidFill>
+                  <a:srgbClr val="767676"/>
+                </a:solidFill>
+              </a:rPr>
+              <a:t>20 / 20</a:t>
             </a:r>
             <a:endParaRPr lang="en-US" sz="900" dirty="0"/>
           </a:p>
@@ -6504,7 +7452,7 @@
                   <a:srgbClr val="767676"/>
                 </a:solidFill>
               </a:rPr>
-              <a:t>3 / 18</a:t>
+              <a:t>3 / 20</a:t>
             </a:r>
             <a:endParaRPr lang="en-US" sz="900" dirty="0"/>
           </a:p>
@@ -6855,7 +7803,7 @@
                   <a:srgbClr val="767676"/>
                 </a:solidFill>
               </a:rPr>
-              <a:t>4 / 18</a:t>
+              <a:t>4 / 20</a:t>
             </a:r>
             <a:endParaRPr lang="en-US" sz="900" dirty="0"/>
           </a:p>
@@ -7206,7 +8154,7 @@
                   <a:srgbClr val="767676"/>
                 </a:solidFill>
               </a:rPr>
-              <a:t>5 / 18</a:t>
+              <a:t>5 / 20</a:t>
             </a:r>
             <a:endParaRPr lang="en-US" sz="900" dirty="0"/>
           </a:p>
@@ -7557,7 +8505,7 @@
                   <a:srgbClr val="767676"/>
                 </a:solidFill>
               </a:rPr>
-              <a:t>6 / 18</a:t>
+              <a:t>6 / 20</a:t>
             </a:r>
             <a:endParaRPr lang="en-US" sz="900" dirty="0"/>
           </a:p>
@@ -7908,7 +8856,7 @@
                   <a:srgbClr val="767676"/>
                 </a:solidFill>
               </a:rPr>
-              <a:t>7 / 18</a:t>
+              <a:t>7 / 20</a:t>
             </a:r>
             <a:endParaRPr lang="en-US" sz="900" dirty="0"/>
           </a:p>
@@ -8259,7 +9207,7 @@
                   <a:srgbClr val="767676"/>
                 </a:solidFill>
               </a:rPr>
-              <a:t>8 / 18</a:t>
+              <a:t>8 / 20</a:t>
             </a:r>
             <a:endParaRPr lang="en-US" sz="900" dirty="0"/>
           </a:p>
@@ -8610,7 +9558,7 @@
                   <a:srgbClr val="767676"/>
                 </a:solidFill>
               </a:rPr>
-              <a:t>9 / 18</a:t>
+              <a:t>9 / 20</a:t>
             </a:r>
             <a:endParaRPr lang="en-US" sz="900" dirty="0"/>
           </a:p>

</xml_diff>

<commit_message>
docs: align workshop documentation and PowerPoint decks
Align bilingual guides, wiki publication, and all four decks.

Closes #58

📚 - Generated by Copilot
</commit_message>
<xml_diff>
--- a/docs/assets/decks/foundry-hosted-agents-workshop-fsi-en.pptx
+++ b/docs/assets/decks/foundry-hosted-agents-workshop-fsi-en.pptx
@@ -23,9 +23,11 @@
     <p:sldId id="271" r:id="rId17"/>
     <p:sldId id="272" r:id="rId18"/>
     <p:sldId id="273" r:id="rId19"/>
+    <p:sldId id="274" r:id="rId20"/>
+    <p:sldId id="275" r:id="rId21"/>
   </p:sldIdLst>
   <p:notesMasterIdLst>
-    <p:notesMasterId r:id="rId20"/>
+    <p:notesMasterId r:id="rId22"/>
   </p:notesMasterIdLst>
   <p:sldSz cx="12188952" cy="6858000"/>
   <p:notesSz cx="6858000" cy="12188952"/>
@@ -1311,7 +1313,8 @@
           <a:p>
             <a:r>
               <a:rPr lang="en-US" dirty="0"/>
-              <a:t/>
+              <a:t>Retained release 39527950931 attempt 2, source 2c3f13b. Staging IQ is fsi-showcase-iq:2, not the quote agent. Production IQ is blocked by a missing Search query role. The original approved native red-team scan failed before scoring. Its approval does not authorize the new protocol shadow. Deferred work: https://github.com/devopsabcs-engineering/foundry-hosted-agents-fsi/issues/49
+Evidence: https://devopsabcs-engineering.github.io/foundry-hosted-agents-fsi/showcase-evidence.html</a:t>
             </a:r>
             <a:endParaRPr lang="en-US" dirty="0"/>
           </a:p>
@@ -1335,6 +1338,98 @@
             <a:fld id="{F7021451-1387-4CA6-816F-3879F97B5CBC}" type="slidenum">
               <a:rPr lang="en-US"/>
               <a:t>18</a:t>
+            </a:fld>
+            <a:endParaRPr lang="en-US"/>
+          </a:p>
+        </p:txBody>
+      </p:sp>
+    </p:spTree>
+    <p:extLst>
+      <p:ext uri="{BB962C8B-B14F-4D97-AF65-F5344CB8AC3E}">
+        <p14:creationId xmlns:p14="http://schemas.microsoft.com/office/powerpoint/2010/main" val="1024086991"/>
+      </p:ext>
+    </p:extLst>
+  </p:cSld>
+  <p:clrMapOvr>
+    <a:masterClrMapping/>
+  </p:clrMapOvr>
+</p:notes>
+</file>
+
+<file path=ppt/notesSlides/notesSlide19.xml><?xml version="1.0" encoding="utf-8"?>
+<p:notes xmlns:a="http://schemas.openxmlformats.org/drawingml/2006/main" xmlns:r="http://schemas.openxmlformats.org/officeDocument/2006/relationships" xmlns:p="http://schemas.openxmlformats.org/presentationml/2006/main">
+  <p:cSld>
+    <p:spTree>
+      <p:nvGrpSpPr>
+        <p:cNvPr id="1" name=""/>
+        <p:cNvGrpSpPr/>
+        <p:nvPr/>
+      </p:nvGrpSpPr>
+      <p:grpSpPr>
+        <a:xfrm>
+          <a:off x="0" y="0"/>
+          <a:ext cx="0" cy="0"/>
+          <a:chOff x="0" y="0"/>
+          <a:chExt cx="0" cy="0"/>
+        </a:xfrm>
+      </p:grpSpPr>
+      <p:sp>
+        <p:nvSpPr>
+          <p:cNvPr id="2" name="Slide Image Placeholder 1"/>
+          <p:cNvSpPr>
+            <a:spLocks noGrp="1" noRot="1" noChangeAspect="1"/>
+          </p:cNvSpPr>
+          <p:nvPr>
+            <p:ph type="sldImg"/>
+          </p:nvPr>
+        </p:nvSpPr>
+        <p:spPr/>
+      </p:sp>
+      <p:sp>
+        <p:nvSpPr>
+          <p:cNvPr id="3" name="Notes Placeholder 2"/>
+          <p:cNvSpPr>
+            <a:spLocks noGrp="1"/>
+          </p:cNvSpPr>
+          <p:nvPr>
+            <p:ph type="body" idx="1"/>
+          </p:nvPr>
+        </p:nvSpPr>
+        <p:spPr/>
+        <p:txBody>
+          <a:bodyPr/>
+          <a:lstStyle/>
+          <a:p>
+            <a:r>
+              <a:rPr lang="en-US" dirty="0"/>
+              <a:t>Allow 3-4 hours for ten exercises. The practice rows are authored synthetic controls, not captured agent responses. Retained screenshots prove only their identified run.
+Guide: https://devopsabcs-engineering.github.io/foundry-hosted-agents-fsi/evaluation-guide.html
+Lab: https://devopsabcs-engineering.github.io/foundry-hosted-agents-fsi/labs/lab-19-evaluation-engineering
+Dataset: https://devopsabcs-engineering.github.io/foundry-hosted-agents-fsi/assets/datasets/portal-practice-en-CA.jsonl
+Deck: https://devopsabcs-engineering.github.io/foundry-hosted-agents-fsi/assets/decks/foundry-evaluation-engineering-en.pptx</a:t>
+            </a:r>
+            <a:endParaRPr lang="en-US" dirty="0"/>
+          </a:p>
+        </p:txBody>
+      </p:sp>
+      <p:sp>
+        <p:nvSpPr>
+          <p:cNvPr id="4" name="Slide Number Placeholder 3"/>
+          <p:cNvSpPr>
+            <a:spLocks noGrp="1"/>
+          </p:cNvSpPr>
+          <p:nvPr>
+            <p:ph type="sldNum" sz="quarter" idx="10"/>
+          </p:nvPr>
+        </p:nvSpPr>
+        <p:spPr/>
+        <p:txBody>
+          <a:bodyPr/>
+          <a:lstStyle/>
+          <a:p>
+            <a:fld id="{F7021451-1387-4CA6-816F-3879F97B5CBC}" type="slidenum">
+              <a:rPr lang="en-US"/>
+              <a:t>19</a:t>
             </a:fld>
             <a:endParaRPr lang="en-US"/>
           </a:p>
@@ -1423,6 +1518,94 @@
             <a:fld id="{F7021451-1387-4CA6-816F-3879F97B5CBC}" type="slidenum">
               <a:rPr lang="en-US"/>
               <a:t>2</a:t>
+            </a:fld>
+            <a:endParaRPr lang="en-US"/>
+          </a:p>
+        </p:txBody>
+      </p:sp>
+    </p:spTree>
+    <p:extLst>
+      <p:ext uri="{BB962C8B-B14F-4D97-AF65-F5344CB8AC3E}">
+        <p14:creationId xmlns:p14="http://schemas.microsoft.com/office/powerpoint/2010/main" val="1024086991"/>
+      </p:ext>
+    </p:extLst>
+  </p:cSld>
+  <p:clrMapOvr>
+    <a:masterClrMapping/>
+  </p:clrMapOvr>
+</p:notes>
+</file>
+
+<file path=ppt/notesSlides/notesSlide20.xml><?xml version="1.0" encoding="utf-8"?>
+<p:notes xmlns:a="http://schemas.openxmlformats.org/drawingml/2006/main" xmlns:r="http://schemas.openxmlformats.org/officeDocument/2006/relationships" xmlns:p="http://schemas.openxmlformats.org/presentationml/2006/main">
+  <p:cSld>
+    <p:spTree>
+      <p:nvGrpSpPr>
+        <p:cNvPr id="1" name=""/>
+        <p:cNvGrpSpPr/>
+        <p:nvPr/>
+      </p:nvGrpSpPr>
+      <p:grpSpPr>
+        <a:xfrm>
+          <a:off x="0" y="0"/>
+          <a:ext cx="0" cy="0"/>
+          <a:chOff x="0" y="0"/>
+          <a:chExt cx="0" cy="0"/>
+        </a:xfrm>
+      </p:grpSpPr>
+      <p:sp>
+        <p:nvSpPr>
+          <p:cNvPr id="2" name="Slide Image Placeholder 1"/>
+          <p:cNvSpPr>
+            <a:spLocks noGrp="1" noRot="1" noChangeAspect="1"/>
+          </p:cNvSpPr>
+          <p:nvPr>
+            <p:ph type="sldImg"/>
+          </p:nvPr>
+        </p:nvSpPr>
+        <p:spPr/>
+      </p:sp>
+      <p:sp>
+        <p:nvSpPr>
+          <p:cNvPr id="3" name="Notes Placeholder 2"/>
+          <p:cNvSpPr>
+            <a:spLocks noGrp="1"/>
+          </p:cNvSpPr>
+          <p:nvPr>
+            <p:ph type="body" idx="1"/>
+          </p:nvPr>
+        </p:nvSpPr>
+        <p:spPr/>
+        <p:txBody>
+          <a:bodyPr/>
+          <a:lstStyle/>
+          <a:p>
+            <a:r>
+              <a:rPr lang="en-US" dirty="0"/>
+              <a:t/>
+            </a:r>
+            <a:endParaRPr lang="en-US" dirty="0"/>
+          </a:p>
+        </p:txBody>
+      </p:sp>
+      <p:sp>
+        <p:nvSpPr>
+          <p:cNvPr id="4" name="Slide Number Placeholder 3"/>
+          <p:cNvSpPr>
+            <a:spLocks noGrp="1"/>
+          </p:cNvSpPr>
+          <p:nvPr>
+            <p:ph type="sldNum" sz="quarter" idx="10"/>
+          </p:nvPr>
+        </p:nvSpPr>
+        <p:spPr/>
+        <p:txBody>
+          <a:bodyPr/>
+          <a:lstStyle/>
+          <a:p>
+            <a:fld id="{F7021451-1387-4CA6-816F-3879F97B5CBC}" type="slidenum">
+              <a:rPr lang="en-US"/>
+              <a:t>20</a:t>
             </a:fld>
             <a:endParaRPr lang="en-US"/>
           </a:p>
@@ -2496,7 +2679,7 @@
                   <a:srgbClr val="767676"/>
                 </a:solidFill>
               </a:rPr>
-              <a:t>1 / 18</a:t>
+              <a:t>1 / 20</a:t>
             </a:r>
             <a:endParaRPr lang="en-US" sz="900" dirty="0"/>
           </a:p>
@@ -2847,7 +3030,7 @@
                   <a:srgbClr val="767676"/>
                 </a:solidFill>
               </a:rPr>
-              <a:t>10 / 18</a:t>
+              <a:t>10 / 20</a:t>
             </a:r>
             <a:endParaRPr lang="en-US" sz="900" dirty="0"/>
           </a:p>
@@ -3198,7 +3381,7 @@
                   <a:srgbClr val="767676"/>
                 </a:solidFill>
               </a:rPr>
-              <a:t>11 / 18</a:t>
+              <a:t>11 / 20</a:t>
             </a:r>
             <a:endParaRPr lang="en-US" sz="900" dirty="0"/>
           </a:p>
@@ -3549,7 +3732,7 @@
                   <a:srgbClr val="767676"/>
                 </a:solidFill>
               </a:rPr>
-              <a:t>12 / 18</a:t>
+              <a:t>12 / 20</a:t>
             </a:r>
             <a:endParaRPr lang="en-US" sz="900" dirty="0"/>
           </a:p>
@@ -3900,7 +4083,7 @@
                   <a:srgbClr val="767676"/>
                 </a:solidFill>
               </a:rPr>
-              <a:t>13 / 18</a:t>
+              <a:t>13 / 20</a:t>
             </a:r>
             <a:endParaRPr lang="en-US" sz="900" dirty="0"/>
           </a:p>
@@ -4251,7 +4434,7 @@
                   <a:srgbClr val="767676"/>
                 </a:solidFill>
               </a:rPr>
-              <a:t>14 / 18</a:t>
+              <a:t>14 / 20</a:t>
             </a:r>
             <a:endParaRPr lang="en-US" sz="900" dirty="0"/>
           </a:p>
@@ -4602,7 +4785,7 @@
                   <a:srgbClr val="767676"/>
                 </a:solidFill>
               </a:rPr>
-              <a:t>15 / 18</a:t>
+              <a:t>15 / 20</a:t>
             </a:r>
             <a:endParaRPr lang="en-US" sz="900" dirty="0"/>
           </a:p>
@@ -4858,7 +5041,7 @@
                 <a:ea typeface="Segoe UI" pitchFamily="34" charset="-122"/>
                 <a:cs typeface="Segoe UI" pitchFamily="34" charset="-120"/>
               </a:rPr>
-              <a:t>Review the exact prohibited-actions taxonomy before a bounded native red-team run</a:t>
+              <a:t>Approved native red-team scan failed before scoring; this is not a safety pass</a:t>
             </a:r>
             <a:endParaRPr lang="en-US" sz="1500" dirty="0"/>
           </a:p>
@@ -4974,7 +5157,7 @@
                   <a:srgbClr val="767676"/>
                 </a:solidFill>
               </a:rPr>
-              <a:t>16 / 18</a:t>
+              <a:t>16 / 20</a:t>
             </a:r>
             <a:endParaRPr lang="en-US" sz="900" dirty="0"/>
           </a:p>
@@ -5325,7 +5508,7 @@
                   <a:srgbClr val="767676"/>
                 </a:solidFill>
               </a:rPr>
-              <a:t>17 / 18</a:t>
+              <a:t>17 / 20</a:t>
             </a:r>
             <a:endParaRPr lang="en-US" sz="900" dirty="0"/>
           </a:p>
@@ -5416,7 +5599,7 @@
                 <a:ea typeface="Segoe UI" pitchFamily="34" charset="-122"/>
                 <a:cs typeface="Segoe UI" pitchFamily="34" charset="-120"/>
               </a:rPr>
-              <a:t>WRAP-UP</a:t>
+              <a:t>SESSION 2 / CURRENT EVIDENCE</a:t>
             </a:r>
             <a:endParaRPr lang="en-US" sz="1100" dirty="0"/>
           </a:p>
@@ -5455,7 +5638,7 @@
                 <a:ea typeface="Segoe UI" pitchFamily="34" charset="-122"/>
                 <a:cs typeface="Segoe UI" pitchFamily="34" charset="-120"/>
               </a:rPr>
-              <a:t>A Retained, Synthetic Customer Demo</a:t>
+              <a:t>Verified and Deferred Are Different</a:t>
             </a:r>
             <a:endParaRPr lang="en-US" sz="2600" dirty="0"/>
           </a:p>
@@ -5518,7 +5701,7 @@
                 <a:ea typeface="Segoe UI" pitchFamily="34" charset="-122"/>
                 <a:cs typeface="Segoe UI" pitchFamily="34" charset="-120"/>
               </a:rPr>
-              <a:t>Every fixture, rulebook, and calculator output is synthetic and non-binding</a:t>
+              <a:t>Retained quote release: staging v6 and production v7; documentation does not redeploy it</a:t>
             </a:r>
             <a:endParaRPr lang="en-US" sz="1500" dirty="0"/>
           </a:p>
@@ -5539,7 +5722,7 @@
                 <a:ea typeface="Segoe UI" pitchFamily="34" charset="-122"/>
                 <a:cs typeface="Segoe UI" pitchFamily="34" charset="-120"/>
               </a:rPr>
-              <a:t>Staging and production are restored; enhancements require separate measured live acceptance</a:t>
+              <a:t>Isolated staging IQ companion v2: 8/8 bilingual checks; production remains unpromoted</a:t>
             </a:r>
             <a:endParaRPr lang="en-US" sz="1500" dirty="0"/>
           </a:p>
@@ -5560,7 +5743,7 @@
                 <a:ea typeface="Segoe UI" pitchFamily="34" charset="-122"/>
                 <a:cs typeface="Segoe UI" pitchFamily="34" charset="-120"/>
               </a:rPr>
-              <a:t>A human reviewer, never the agent, decides whether a draft can reach the applicant</a:t>
+              <a:t>Native Content Understanding invoice extraction passed in staging and production</a:t>
             </a:r>
             <a:endParaRPr lang="en-US" sz="1500" dirty="0"/>
           </a:p>
@@ -5581,7 +5764,7 @@
                 <a:ea typeface="Segoe UI" pitchFamily="34" charset="-122"/>
                 <a:cs typeface="Segoe UI" pitchFamily="34" charset="-120"/>
               </a:rPr>
-              <a:t>Full bilingual step-by-step labs: this deck’s companion GitHub Pages site</a:t>
+              <a:t>Protocol-only red-team shadow passes offline tests, not native acceptance or scan approval</a:t>
             </a:r>
             <a:endParaRPr lang="en-US" sz="1500" dirty="0"/>
           </a:p>
@@ -5648,7 +5831,7 @@
       </p:sp>
       <p:sp>
         <p:nvSpPr>
-          <p:cNvPr id="9" name="Text 7"/>
+          <p:cNvPr id="10" name="Text 7"/>
           <p:cNvSpPr/>
           <p:nvPr/>
         </p:nvSpPr>
@@ -5676,7 +5859,358 @@
                   <a:srgbClr val="767676"/>
                 </a:solidFill>
               </a:rPr>
-              <a:t>18 / 18</a:t>
+              <a:t>18 / 20</a:t>
+            </a:r>
+            <a:endParaRPr lang="en-US" sz="900" dirty="0"/>
+          </a:p>
+        </p:txBody>
+      </p:sp>
+    </p:spTree>
+  </p:cSld>
+  <p:clrMapOvr>
+    <a:masterClrMapping/>
+  </p:clrMapOvr>
+</p:sld>
+</file>
+
+<file path=ppt/slides/slide19.xml><?xml version="1.0" encoding="utf-8"?>
+<p:sld xmlns:a="http://schemas.openxmlformats.org/drawingml/2006/main" xmlns:r="http://schemas.openxmlformats.org/officeDocument/2006/relationships" xmlns:p="http://schemas.openxmlformats.org/presentationml/2006/main">
+  <p:cSld name="Slide 19">
+    <p:bg>
+      <p:bgPr>
+        <a:solidFill>
+          <a:srgbClr val="FAFBFC"/>
+        </a:solidFill>
+      </p:bgPr>
+    </p:bg>
+    <p:spTree>
+      <p:nvGrpSpPr>
+        <p:cNvPr id="1" name=""/>
+        <p:cNvGrpSpPr/>
+        <p:nvPr/>
+      </p:nvGrpSpPr>
+      <p:grpSpPr>
+        <a:xfrm>
+          <a:off x="0" y="0"/>
+          <a:ext cx="0" cy="0"/>
+          <a:chOff x="0" y="0"/>
+          <a:chExt cx="0" cy="0"/>
+        </a:xfrm>
+      </p:grpSpPr>
+      <p:sp>
+        <p:nvSpPr>
+          <p:cNvPr id="2" name="Shape 0"/>
+          <p:cNvSpPr/>
+          <p:nvPr/>
+        </p:nvSpPr>
+        <p:spPr>
+          <a:xfrm>
+            <a:off x="0" y="0"/>
+            <a:ext cx="12188952" cy="82296"/>
+          </a:xfrm>
+          <a:prstGeom prst="rect">
+            <a:avLst/>
+          </a:prstGeom>
+          <a:solidFill>
+            <a:srgbClr val="0078D4"/>
+          </a:solidFill>
+          <a:ln/>
+        </p:spPr>
+      </p:sp>
+      <p:sp>
+        <p:nvSpPr>
+          <p:cNvPr id="3" name="Text 1"/>
+          <p:cNvSpPr/>
+          <p:nvPr/>
+        </p:nvSpPr>
+        <p:spPr>
+          <a:xfrm>
+            <a:off x="457200" y="292608"/>
+            <a:ext cx="11247120" cy="274320"/>
+          </a:xfrm>
+          <a:prstGeom prst="rect">
+            <a:avLst/>
+          </a:prstGeom>
+          <a:noFill/>
+          <a:ln/>
+        </p:spPr>
+        <p:txBody>
+          <a:bodyPr wrap="square" rtlCol="0" anchor="ctr"/>
+          <a:lstStyle/>
+          <a:p>
+            <a:pPr indent="0" marL="0">
+              <a:buNone/>
+            </a:pPr>
+            <a:r>
+              <a:rPr lang="en-US" sz="1100" b="1" spc="100" kern="0" dirty="0">
+                <a:solidFill>
+                  <a:srgbClr val="0078D4"/>
+                </a:solidFill>
+                <a:latin typeface="Segoe UI" pitchFamily="34" charset="0"/>
+                <a:ea typeface="Segoe UI" pitchFamily="34" charset="-122"/>
+                <a:cs typeface="Segoe UI" pitchFamily="34" charset="-120"/>
+              </a:rPr>
+              <a:t>LAB 19 / EVALUATION ENGINEERING</a:t>
+            </a:r>
+            <a:endParaRPr lang="en-US" sz="1100" dirty="0"/>
+          </a:p>
+        </p:txBody>
+      </p:sp>
+      <p:sp>
+        <p:nvSpPr>
+          <p:cNvPr id="4" name="Text 2"/>
+          <p:cNvSpPr/>
+          <p:nvPr/>
+        </p:nvSpPr>
+        <p:spPr>
+          <a:xfrm>
+            <a:off x="457200" y="548640"/>
+            <a:ext cx="11247120" cy="640080"/>
+          </a:xfrm>
+          <a:prstGeom prst="rect">
+            <a:avLst/>
+          </a:prstGeom>
+          <a:noFill/>
+          <a:ln/>
+        </p:spPr>
+        <p:txBody>
+          <a:bodyPr wrap="square" rtlCol="0" anchor="ctr"/>
+          <a:lstStyle/>
+          <a:p>
+            <a:pPr indent="0" marL="0">
+              <a:buNone/>
+            </a:pPr>
+            <a:r>
+              <a:rPr lang="en-US" sz="2600" b="1" dirty="0">
+                <a:solidFill>
+                  <a:srgbClr val="001B3D"/>
+                </a:solidFill>
+                <a:latin typeface="Segoe UI" pitchFamily="34" charset="0"/>
+                <a:ea typeface="Segoe UI" pitchFamily="34" charset="-122"/>
+                <a:cs typeface="Segoe UI" pitchFamily="34" charset="-120"/>
+              </a:rPr>
+              <a:t>Continue with the Evaluation Deep Lab</a:t>
+            </a:r>
+            <a:endParaRPr lang="en-US" sz="2600" dirty="0"/>
+          </a:p>
+        </p:txBody>
+      </p:sp>
+      <p:sp>
+        <p:nvSpPr>
+          <p:cNvPr id="5" name="Shape 3"/>
+          <p:cNvSpPr/>
+          <p:nvPr/>
+        </p:nvSpPr>
+        <p:spPr>
+          <a:xfrm>
+            <a:off x="457200" y="1188720"/>
+            <a:ext cx="11247120" cy="10973"/>
+          </a:xfrm>
+          <a:prstGeom prst="rect">
+            <a:avLst/>
+          </a:prstGeom>
+          <a:solidFill>
+            <a:srgbClr val="E1E5E8"/>
+          </a:solidFill>
+          <a:ln/>
+        </p:spPr>
+      </p:sp>
+      <p:sp>
+        <p:nvSpPr>
+          <p:cNvPr id="6" name="Text 4"/>
+          <p:cNvSpPr/>
+          <p:nvPr/>
+        </p:nvSpPr>
+        <p:spPr>
+          <a:xfrm>
+            <a:off x="548640" y="1463040"/>
+            <a:ext cx="11064240" cy="5029200"/>
+          </a:xfrm>
+          <a:prstGeom prst="rect">
+            <a:avLst/>
+          </a:prstGeom>
+          <a:noFill/>
+          <a:ln/>
+        </p:spPr>
+        <p:txBody>
+          <a:bodyPr wrap="square" rtlCol="0" anchor="t"/>
+          <a:lstStyle/>
+          <a:p>
+            <a:pPr marL="254000" indent="-254000">
+              <a:lnSpc>
+                <a:spcPct val="125000"/>
+              </a:lnSpc>
+              <a:buSzPct val="100000"/>
+              <a:buChar char="●"/>
+            </a:pPr>
+            <a:r>
+              <a:rPr lang="en-US" sz="1500" dirty="0">
+                <a:solidFill>
+                  <a:srgbClr val="1A1A1A"/>
+                </a:solidFill>
+                <a:latin typeface="Segoe UI" pitchFamily="34" charset="0"/>
+                <a:ea typeface="Segoe UI" pitchFamily="34" charset="-122"/>
+                <a:cs typeface="Segoe UI" pitchFamily="34" charset="-120"/>
+              </a:rPr>
+              <a:t>Complete curriculum: local Labs 00-09, pilot 10-14, native 15-18 and evaluation Lab 19</a:t>
+            </a:r>
+            <a:endParaRPr lang="en-US" sz="1500" dirty="0"/>
+          </a:p>
+          <a:p>
+            <a:pPr marL="254000" indent="-254000">
+              <a:lnSpc>
+                <a:spcPct val="125000"/>
+              </a:lnSpc>
+              <a:buSzPct val="100000"/>
+              <a:buChar char="●"/>
+            </a:pPr>
+            <a:r>
+              <a:rPr lang="en-US" sz="1500" dirty="0">
+                <a:solidFill>
+                  <a:srgbClr val="1A1A1A"/>
+                </a:solidFill>
+                <a:latin typeface="Segoe UI" pitchFamily="34" charset="0"/>
+                <a:ea typeface="Segoe UI" pitchFamily="34" charset="-122"/>
+                <a:cs typeface="Segoe UI" pitchFamily="34" charset="-120"/>
+              </a:rPr>
+              <a:t>Read-only portal walkthrough: overview, detailed results and three built-in evaluator captures</a:t>
+            </a:r>
+            <a:endParaRPr lang="en-US" sz="1500" dirty="0"/>
+          </a:p>
+          <a:p>
+            <a:pPr marL="254000" indent="-254000">
+              <a:lnSpc>
+                <a:spcPct val="125000"/>
+              </a:lnSpc>
+              <a:buSzPct val="100000"/>
+              <a:buChar char="●"/>
+            </a:pPr>
+            <a:r>
+              <a:rPr lang="en-US" sz="1500" dirty="0">
+                <a:solidFill>
+                  <a:srgbClr val="1A1A1A"/>
+                </a:solidFill>
+                <a:latin typeface="Segoe UI" pitchFamily="34" charset="0"/>
+                <a:ea typeface="Segoe UI" pitchFamily="34" charset="-122"/>
+                <a:cs typeface="Segoe UI" pitchFamily="34" charset="-120"/>
+              </a:rPr>
+              <a:t>Use supplied EN/FR synthetic JSONL controls; uploads and paid submissions need approval</a:t>
+            </a:r>
+            <a:endParaRPr lang="en-US" sz="1500" dirty="0"/>
+          </a:p>
+          <a:p>
+            <a:pPr marL="254000" indent="-254000">
+              <a:lnSpc>
+                <a:spcPct val="125000"/>
+              </a:lnSpc>
+              <a:buSzPct val="100000"/>
+              <a:buChar char="●"/>
+            </a:pPr>
+            <a:r>
+              <a:rPr lang="en-US" sz="1500" dirty="0">
+                <a:solidFill>
+                  <a:srgbClr val="1A1A1A"/>
+                </a:solidFill>
+                <a:latin typeface="Segoe UI" pitchFamily="34" charset="0"/>
+                <a:ea typeface="Segoe UI" pitchFamily="34" charset="-122"/>
+                <a:cs typeface="Segoe UI" pitchFamily="34" charset="-120"/>
+              </a:rPr>
+              <a:t>Dedicated evaluation decks: 37 editable slides per language, with instructor notes</a:t>
+            </a:r>
+            <a:endParaRPr lang="en-US" sz="1500" dirty="0"/>
+          </a:p>
+        </p:txBody>
+      </p:sp>
+      <p:sp>
+        <p:nvSpPr>
+          <p:cNvPr id="7" name="Shape 5"/>
+          <p:cNvSpPr/>
+          <p:nvPr/>
+        </p:nvSpPr>
+        <p:spPr>
+          <a:xfrm>
+            <a:off x="0" y="6784848"/>
+            <a:ext cx="12188952" cy="27432"/>
+          </a:xfrm>
+          <a:prstGeom prst="rect">
+            <a:avLst/>
+          </a:prstGeom>
+          <a:solidFill>
+            <a:srgbClr val="E1E5E8"/>
+          </a:solidFill>
+          <a:ln/>
+        </p:spPr>
+      </p:sp>
+      <p:sp>
+        <p:nvSpPr>
+          <p:cNvPr id="8" name="Text 6"/>
+          <p:cNvSpPr/>
+          <p:nvPr/>
+        </p:nvSpPr>
+        <p:spPr>
+          <a:xfrm>
+            <a:off x="457200" y="6537960"/>
+            <a:ext cx="8229600" cy="256032"/>
+          </a:xfrm>
+          <a:prstGeom prst="rect">
+            <a:avLst/>
+          </a:prstGeom>
+          <a:noFill/>
+          <a:ln/>
+        </p:spPr>
+        <p:txBody>
+          <a:bodyPr wrap="square" rtlCol="0" anchor="ctr"/>
+          <a:lstStyle/>
+          <a:p>
+            <a:pPr indent="0" marL="0">
+              <a:buNone/>
+            </a:pPr>
+            <a:r>
+              <a:rPr lang="en-US" sz="900" dirty="0">
+                <a:solidFill>
+                  <a:srgbClr val="767676"/>
+                </a:solidFill>
+                <a:latin typeface="Segoe UI" pitchFamily="34" charset="0"/>
+                <a:ea typeface="Segoe UI" pitchFamily="34" charset="-122"/>
+                <a:cs typeface="Segoe UI" pitchFamily="34" charset="-120"/>
+              </a:rPr>
+              <a:t>Desjardins Bilingual Hosted Agents Workshop</a:t>
+            </a:r>
+            <a:endParaRPr lang="en-US" sz="900" dirty="0"/>
+          </a:p>
+        </p:txBody>
+      </p:sp>
+      <p:sp>
+        <p:nvSpPr>
+          <p:cNvPr id="10" name="Text 7"/>
+          <p:cNvSpPr/>
+          <p:nvPr/>
+        </p:nvSpPr>
+        <p:spPr>
+          <a:xfrm>
+            <a:off x="11338560" y="6528816"/>
+            <a:ext cx="548640" cy="219456"/>
+          </a:xfrm>
+          <a:prstGeom prst="rect">
+            <a:avLst/>
+          </a:prstGeom>
+          <a:noFill/>
+          <a:ln/>
+        </p:spPr>
+        <p:txBody>
+          <a:bodyPr wrap="square" rtlCol="0" anchor="ctr"/>
+          <a:lstStyle/>
+          <a:p>
+            <a:pPr algn="r" indent="0" marL="0">
+              <a:buNone/>
+            </a:pPr>
+            <a:r>
+              <a:rPr lang="en-US" sz="900" dirty="0">
+                <a:solidFill>
+                  <a:srgbClr val="767676"/>
+                </a:solidFill>
+              </a:rPr>
+              <a:t>19 / 20</a:t>
             </a:r>
             <a:endParaRPr lang="en-US" sz="900" dirty="0"/>
           </a:p>
@@ -6062,6 +6596,69 @@
             </a:r>
             <a:endParaRPr lang="en-US" sz="1500" dirty="0"/>
           </a:p>
+          <a:p>
+            <a:pPr marL="254000" indent="-254000">
+              <a:lnSpc>
+                <a:spcPct val="125000"/>
+              </a:lnSpc>
+              <a:buSzPct val="100000"/>
+              <a:buChar char="●"/>
+            </a:pPr>
+            <a:r>
+              <a:rPr lang="en-US" sz="1500" dirty="0">
+                <a:solidFill>
+                  <a:srgbClr val="1A1A1A"/>
+                </a:solidFill>
+                <a:latin typeface="Segoe UI" pitchFamily="34" charset="0"/>
+                <a:ea typeface="Segoe UI" pitchFamily="34" charset="-122"/>
+                <a:cs typeface="Segoe UI" pitchFamily="34" charset="-120"/>
+              </a:rPr>
+              <a:t>Labs 10-14: controlled pilot surfaces</a:t>
+            </a:r>
+            <a:endParaRPr lang="en-US" sz="1500" dirty="0"/>
+          </a:p>
+          <a:p>
+            <a:pPr marL="254000" indent="-254000">
+              <a:lnSpc>
+                <a:spcPct val="125000"/>
+              </a:lnSpc>
+              <a:buSzPct val="100000"/>
+              <a:buChar char="●"/>
+            </a:pPr>
+            <a:r>
+              <a:rPr lang="en-US" sz="1500" dirty="0">
+                <a:solidFill>
+                  <a:srgbClr val="1A1A1A"/>
+                </a:solidFill>
+                <a:latin typeface="Segoe UI" pitchFamily="34" charset="0"/>
+                <a:ea typeface="Segoe UI" pitchFamily="34" charset="-122"/>
+                <a:cs typeface="Segoe UI" pitchFamily="34" charset="-120"/>
+              </a:rPr>
+              <a:t>Labs 15-18: isolated native showcase</a:t>
+            </a:r>
+            <a:endParaRPr lang="en-US" sz="1500" dirty="0"/>
+          </a:p>
+          <a:p>
+            <a:pPr marL="254000" indent="-254000">
+              <a:lnSpc>
+                <a:spcPct val="125000"/>
+              </a:lnSpc>
+              <a:buSzPct val="100000"/>
+              <a:buChar char="●"/>
+            </a:pPr>
+            <a:r>
+              <a:rPr lang="en-US" sz="1500" dirty="0">
+                <a:solidFill>
+                  <a:srgbClr val="1A1A1A"/>
+                </a:solidFill>
+                <a:latin typeface="Segoe UI" pitchFamily="34" charset="0"/>
+                <a:ea typeface="Segoe UI" pitchFamily="34" charset="-122"/>
+                <a:cs typeface="Segoe UI" pitchFamily="34" charset="-120"/>
+              </a:rPr>
+              <a:t>Lab 19: evaluation engineering deep lab</a:t>
+            </a:r>
+            <a:endParaRPr lang="en-US" sz="1500" dirty="0"/>
+          </a:p>
         </p:txBody>
       </p:sp>
       <p:sp>
@@ -6153,7 +6750,358 @@
                   <a:srgbClr val="767676"/>
                 </a:solidFill>
               </a:rPr>
-              <a:t>2 / 18</a:t>
+              <a:t>2 / 20</a:t>
+            </a:r>
+            <a:endParaRPr lang="en-US" sz="900" dirty="0"/>
+          </a:p>
+        </p:txBody>
+      </p:sp>
+    </p:spTree>
+  </p:cSld>
+  <p:clrMapOvr>
+    <a:masterClrMapping/>
+  </p:clrMapOvr>
+</p:sld>
+</file>
+
+<file path=ppt/slides/slide20.xml><?xml version="1.0" encoding="utf-8"?>
+<p:sld xmlns:a="http://schemas.openxmlformats.org/drawingml/2006/main" xmlns:r="http://schemas.openxmlformats.org/officeDocument/2006/relationships" xmlns:p="http://schemas.openxmlformats.org/presentationml/2006/main">
+  <p:cSld name="Slide 20">
+    <p:bg>
+      <p:bgPr>
+        <a:solidFill>
+          <a:srgbClr val="FAFBFC"/>
+        </a:solidFill>
+      </p:bgPr>
+    </p:bg>
+    <p:spTree>
+      <p:nvGrpSpPr>
+        <p:cNvPr id="1" name=""/>
+        <p:cNvGrpSpPr/>
+        <p:nvPr/>
+      </p:nvGrpSpPr>
+      <p:grpSpPr>
+        <a:xfrm>
+          <a:off x="0" y="0"/>
+          <a:ext cx="0" cy="0"/>
+          <a:chOff x="0" y="0"/>
+          <a:chExt cx="0" cy="0"/>
+        </a:xfrm>
+      </p:grpSpPr>
+      <p:sp>
+        <p:nvSpPr>
+          <p:cNvPr id="2" name="Shape 0"/>
+          <p:cNvSpPr/>
+          <p:nvPr/>
+        </p:nvSpPr>
+        <p:spPr>
+          <a:xfrm>
+            <a:off x="0" y="0"/>
+            <a:ext cx="12188952" cy="82296"/>
+          </a:xfrm>
+          <a:prstGeom prst="rect">
+            <a:avLst/>
+          </a:prstGeom>
+          <a:solidFill>
+            <a:srgbClr val="0078D4"/>
+          </a:solidFill>
+          <a:ln/>
+        </p:spPr>
+      </p:sp>
+      <p:sp>
+        <p:nvSpPr>
+          <p:cNvPr id="3" name="Text 1"/>
+          <p:cNvSpPr/>
+          <p:nvPr/>
+        </p:nvSpPr>
+        <p:spPr>
+          <a:xfrm>
+            <a:off x="457200" y="292608"/>
+            <a:ext cx="11247120" cy="274320"/>
+          </a:xfrm>
+          <a:prstGeom prst="rect">
+            <a:avLst/>
+          </a:prstGeom>
+          <a:noFill/>
+          <a:ln/>
+        </p:spPr>
+        <p:txBody>
+          <a:bodyPr wrap="square" rtlCol="0" anchor="ctr"/>
+          <a:lstStyle/>
+          <a:p>
+            <a:pPr indent="0" marL="0">
+              <a:buNone/>
+            </a:pPr>
+            <a:r>
+              <a:rPr lang="en-US" sz="1100" b="1" spc="100" kern="0" dirty="0">
+                <a:solidFill>
+                  <a:srgbClr val="0078D4"/>
+                </a:solidFill>
+                <a:latin typeface="Segoe UI" pitchFamily="34" charset="0"/>
+                <a:ea typeface="Segoe UI" pitchFamily="34" charset="-122"/>
+                <a:cs typeface="Segoe UI" pitchFamily="34" charset="-120"/>
+              </a:rPr>
+              <a:t>WRAP-UP</a:t>
+            </a:r>
+            <a:endParaRPr lang="en-US" sz="1100" dirty="0"/>
+          </a:p>
+        </p:txBody>
+      </p:sp>
+      <p:sp>
+        <p:nvSpPr>
+          <p:cNvPr id="4" name="Text 2"/>
+          <p:cNvSpPr/>
+          <p:nvPr/>
+        </p:nvSpPr>
+        <p:spPr>
+          <a:xfrm>
+            <a:off x="457200" y="548640"/>
+            <a:ext cx="11247120" cy="640080"/>
+          </a:xfrm>
+          <a:prstGeom prst="rect">
+            <a:avLst/>
+          </a:prstGeom>
+          <a:noFill/>
+          <a:ln/>
+        </p:spPr>
+        <p:txBody>
+          <a:bodyPr wrap="square" rtlCol="0" anchor="ctr"/>
+          <a:lstStyle/>
+          <a:p>
+            <a:pPr indent="0" marL="0">
+              <a:buNone/>
+            </a:pPr>
+            <a:r>
+              <a:rPr lang="en-US" sz="2600" b="1" dirty="0">
+                <a:solidFill>
+                  <a:srgbClr val="001B3D"/>
+                </a:solidFill>
+                <a:latin typeface="Segoe UI" pitchFamily="34" charset="0"/>
+                <a:ea typeface="Segoe UI" pitchFamily="34" charset="-122"/>
+                <a:cs typeface="Segoe UI" pitchFamily="34" charset="-120"/>
+              </a:rPr>
+              <a:t>A Retained, Synthetic Customer Demo</a:t>
+            </a:r>
+            <a:endParaRPr lang="en-US" sz="2600" dirty="0"/>
+          </a:p>
+        </p:txBody>
+      </p:sp>
+      <p:sp>
+        <p:nvSpPr>
+          <p:cNvPr id="5" name="Shape 3"/>
+          <p:cNvSpPr/>
+          <p:nvPr/>
+        </p:nvSpPr>
+        <p:spPr>
+          <a:xfrm>
+            <a:off x="457200" y="1188720"/>
+            <a:ext cx="11247120" cy="10973"/>
+          </a:xfrm>
+          <a:prstGeom prst="rect">
+            <a:avLst/>
+          </a:prstGeom>
+          <a:solidFill>
+            <a:srgbClr val="E1E5E8"/>
+          </a:solidFill>
+          <a:ln/>
+        </p:spPr>
+      </p:sp>
+      <p:sp>
+        <p:nvSpPr>
+          <p:cNvPr id="6" name="Text 4"/>
+          <p:cNvSpPr/>
+          <p:nvPr/>
+        </p:nvSpPr>
+        <p:spPr>
+          <a:xfrm>
+            <a:off x="548640" y="1463040"/>
+            <a:ext cx="11064240" cy="5029200"/>
+          </a:xfrm>
+          <a:prstGeom prst="rect">
+            <a:avLst/>
+          </a:prstGeom>
+          <a:noFill/>
+          <a:ln/>
+        </p:spPr>
+        <p:txBody>
+          <a:bodyPr wrap="square" rtlCol="0" anchor="t"/>
+          <a:lstStyle/>
+          <a:p>
+            <a:pPr marL="254000" indent="-254000">
+              <a:lnSpc>
+                <a:spcPct val="125000"/>
+              </a:lnSpc>
+              <a:buSzPct val="100000"/>
+              <a:buChar char="●"/>
+            </a:pPr>
+            <a:r>
+              <a:rPr lang="en-US" sz="1500" dirty="0">
+                <a:solidFill>
+                  <a:srgbClr val="1A1A1A"/>
+                </a:solidFill>
+                <a:latin typeface="Segoe UI" pitchFamily="34" charset="0"/>
+                <a:ea typeface="Segoe UI" pitchFamily="34" charset="-122"/>
+                <a:cs typeface="Segoe UI" pitchFamily="34" charset="-120"/>
+              </a:rPr>
+              <a:t>Every fixture, rulebook, and calculator output is synthetic and non-binding</a:t>
+            </a:r>
+            <a:endParaRPr lang="en-US" sz="1500" dirty="0"/>
+          </a:p>
+          <a:p>
+            <a:pPr marL="254000" indent="-254000">
+              <a:lnSpc>
+                <a:spcPct val="125000"/>
+              </a:lnSpc>
+              <a:buSzPct val="100000"/>
+              <a:buChar char="●"/>
+            </a:pPr>
+            <a:r>
+              <a:rPr lang="en-US" sz="1500" dirty="0">
+                <a:solidFill>
+                  <a:srgbClr val="1A1A1A"/>
+                </a:solidFill>
+                <a:latin typeface="Segoe UI" pitchFamily="34" charset="0"/>
+                <a:ea typeface="Segoe UI" pitchFamily="34" charset="-122"/>
+                <a:cs typeface="Segoe UI" pitchFamily="34" charset="-120"/>
+              </a:rPr>
+              <a:t>Staging and production are restored; enhancements require separate measured live acceptance</a:t>
+            </a:r>
+            <a:endParaRPr lang="en-US" sz="1500" dirty="0"/>
+          </a:p>
+          <a:p>
+            <a:pPr marL="254000" indent="-254000">
+              <a:lnSpc>
+                <a:spcPct val="125000"/>
+              </a:lnSpc>
+              <a:buSzPct val="100000"/>
+              <a:buChar char="●"/>
+            </a:pPr>
+            <a:r>
+              <a:rPr lang="en-US" sz="1500" dirty="0">
+                <a:solidFill>
+                  <a:srgbClr val="1A1A1A"/>
+                </a:solidFill>
+                <a:latin typeface="Segoe UI" pitchFamily="34" charset="0"/>
+                <a:ea typeface="Segoe UI" pitchFamily="34" charset="-122"/>
+                <a:cs typeface="Segoe UI" pitchFamily="34" charset="-120"/>
+              </a:rPr>
+              <a:t>A human reviewer, never the agent, decides whether a draft can reach the applicant</a:t>
+            </a:r>
+            <a:endParaRPr lang="en-US" sz="1500" dirty="0"/>
+          </a:p>
+          <a:p>
+            <a:pPr marL="254000" indent="-254000">
+              <a:lnSpc>
+                <a:spcPct val="125000"/>
+              </a:lnSpc>
+              <a:buSzPct val="100000"/>
+              <a:buChar char="●"/>
+            </a:pPr>
+            <a:r>
+              <a:rPr lang="en-US" sz="1500" dirty="0">
+                <a:solidFill>
+                  <a:srgbClr val="1A1A1A"/>
+                </a:solidFill>
+                <a:latin typeface="Segoe UI" pitchFamily="34" charset="0"/>
+                <a:ea typeface="Segoe UI" pitchFamily="34" charset="-122"/>
+                <a:cs typeface="Segoe UI" pitchFamily="34" charset="-120"/>
+              </a:rPr>
+              <a:t>Full bilingual step-by-step labs: this deck’s companion GitHub Pages site</a:t>
+            </a:r>
+            <a:endParaRPr lang="en-US" sz="1500" dirty="0"/>
+          </a:p>
+        </p:txBody>
+      </p:sp>
+      <p:sp>
+        <p:nvSpPr>
+          <p:cNvPr id="7" name="Shape 5"/>
+          <p:cNvSpPr/>
+          <p:nvPr/>
+        </p:nvSpPr>
+        <p:spPr>
+          <a:xfrm>
+            <a:off x="0" y="6784848"/>
+            <a:ext cx="12188952" cy="27432"/>
+          </a:xfrm>
+          <a:prstGeom prst="rect">
+            <a:avLst/>
+          </a:prstGeom>
+          <a:solidFill>
+            <a:srgbClr val="E1E5E8"/>
+          </a:solidFill>
+          <a:ln/>
+        </p:spPr>
+      </p:sp>
+      <p:sp>
+        <p:nvSpPr>
+          <p:cNvPr id="8" name="Text 6"/>
+          <p:cNvSpPr/>
+          <p:nvPr/>
+        </p:nvSpPr>
+        <p:spPr>
+          <a:xfrm>
+            <a:off x="457200" y="6537960"/>
+            <a:ext cx="8229600" cy="256032"/>
+          </a:xfrm>
+          <a:prstGeom prst="rect">
+            <a:avLst/>
+          </a:prstGeom>
+          <a:noFill/>
+          <a:ln/>
+        </p:spPr>
+        <p:txBody>
+          <a:bodyPr wrap="square" rtlCol="0" anchor="ctr"/>
+          <a:lstStyle/>
+          <a:p>
+            <a:pPr indent="0" marL="0">
+              <a:buNone/>
+            </a:pPr>
+            <a:r>
+              <a:rPr lang="en-US" sz="900" dirty="0">
+                <a:solidFill>
+                  <a:srgbClr val="767676"/>
+                </a:solidFill>
+                <a:latin typeface="Segoe UI" pitchFamily="34" charset="0"/>
+                <a:ea typeface="Segoe UI" pitchFamily="34" charset="-122"/>
+                <a:cs typeface="Segoe UI" pitchFamily="34" charset="-120"/>
+              </a:rPr>
+              <a:t>Desjardins Bilingual Hosted Agents Workshop</a:t>
+            </a:r>
+            <a:endParaRPr lang="en-US" sz="900" dirty="0"/>
+          </a:p>
+        </p:txBody>
+      </p:sp>
+      <p:sp>
+        <p:nvSpPr>
+          <p:cNvPr id="9" name="Text 7"/>
+          <p:cNvSpPr/>
+          <p:nvPr/>
+        </p:nvSpPr>
+        <p:spPr>
+          <a:xfrm>
+            <a:off x="11338560" y="6528816"/>
+            <a:ext cx="548640" cy="219456"/>
+          </a:xfrm>
+          <a:prstGeom prst="rect">
+            <a:avLst/>
+          </a:prstGeom>
+          <a:noFill/>
+          <a:ln/>
+        </p:spPr>
+        <p:txBody>
+          <a:bodyPr wrap="square" rtlCol="0" anchor="ctr"/>
+          <a:lstStyle/>
+          <a:p>
+            <a:pPr algn="r" indent="0" marL="0">
+              <a:buNone/>
+            </a:pPr>
+            <a:r>
+              <a:rPr lang="en-US" sz="900" dirty="0">
+                <a:solidFill>
+                  <a:srgbClr val="767676"/>
+                </a:solidFill>
+              </a:rPr>
+              <a:t>20 / 20</a:t>
             </a:r>
             <a:endParaRPr lang="en-US" sz="900" dirty="0"/>
           </a:p>
@@ -6504,7 +7452,7 @@
                   <a:srgbClr val="767676"/>
                 </a:solidFill>
               </a:rPr>
-              <a:t>3 / 18</a:t>
+              <a:t>3 / 20</a:t>
             </a:r>
             <a:endParaRPr lang="en-US" sz="900" dirty="0"/>
           </a:p>
@@ -6855,7 +7803,7 @@
                   <a:srgbClr val="767676"/>
                 </a:solidFill>
               </a:rPr>
-              <a:t>4 / 18</a:t>
+              <a:t>4 / 20</a:t>
             </a:r>
             <a:endParaRPr lang="en-US" sz="900" dirty="0"/>
           </a:p>
@@ -7206,7 +8154,7 @@
                   <a:srgbClr val="767676"/>
                 </a:solidFill>
               </a:rPr>
-              <a:t>5 / 18</a:t>
+              <a:t>5 / 20</a:t>
             </a:r>
             <a:endParaRPr lang="en-US" sz="900" dirty="0"/>
           </a:p>
@@ -7557,7 +8505,7 @@
                   <a:srgbClr val="767676"/>
                 </a:solidFill>
               </a:rPr>
-              <a:t>6 / 18</a:t>
+              <a:t>6 / 20</a:t>
             </a:r>
             <a:endParaRPr lang="en-US" sz="900" dirty="0"/>
           </a:p>
@@ -7908,7 +8856,7 @@
                   <a:srgbClr val="767676"/>
                 </a:solidFill>
               </a:rPr>
-              <a:t>7 / 18</a:t>
+              <a:t>7 / 20</a:t>
             </a:r>
             <a:endParaRPr lang="en-US" sz="900" dirty="0"/>
           </a:p>
@@ -8259,7 +9207,7 @@
                   <a:srgbClr val="767676"/>
                 </a:solidFill>
               </a:rPr>
-              <a:t>8 / 18</a:t>
+              <a:t>8 / 20</a:t>
             </a:r>
             <a:endParaRPr lang="en-US" sz="900" dirty="0"/>
           </a:p>
@@ -8610,7 +9558,7 @@
                   <a:srgbClr val="767676"/>
                 </a:solidFill>
               </a:rPr>
-              <a:t>9 / 18</a:t>
+              <a:t>9 / 20</a:t>
             </a:r>
             <a:endParaRPr lang="en-US" sz="900" dirty="0"/>
           </a:p>

</xml_diff>